<commit_message>
Add speech script as .docx and rebalance the timeline
Acrescenta 04_FALAS_EM_SEQUENCIA.docx: o texto corrido de tudo o que o
apresentador fala, do primeiro ao último slide, com rubricas de palco em
itálico e um anexo com 13 respostas prontas para a arguição. O script
build_falas.js (docx-js) regenera o arquivo.

Ao cronometrar o texto, a primeira versão somava 2.138 palavras — cerca de
16,4 min a 130 palavras/min, acima do limite de 15 min da Jornada. O texto
foi enxugado para 1.827 palavras (~14,1 min a 130 ppm), concentrando os
cortes nos slides 4, 5, 7 e 8, sem remover o objetivo, a rastreabilidade
temporal, o achado de custo nem a frase de encerramento.

A linha do tempo foi reequilibrada (slide 4: 3:15–6:00; slide 5: 6:00–7:45;
slide 6: 7:45–10:05; slide 7: 10:05–12:00) e sincronizada nos três
artefatos: notas do .pptx, roteiro e o novo .docx.

Co-Authored-By: Claude Opus 5 <noreply@anthropic.com>
Claude-Session: https://claude.ai/code/session_012UH4bfwebhDeQ1wsHpeLQQ
</commit_message>
<xml_diff>
--- a/docs/apresentacao/APRESENTACAO_JIC_2026_Meloni.pptx
+++ b/docs/apresentacao/APRESENTACAO_JIC_2026_Meloni.pptx
@@ -708,7 +708,7 @@
           <a:lstStyle/>
           <a:p>
             <a:r>
-              <a:t>METODOLOGIA – PIPELINE (3:15–6:15). Este é o slide central: ande pelas cinco caixas.</a:t>
+              <a:t>METODOLOGIA – PIPELINE (3:15–6:00). Este é o slide central: ande pelas cinco caixas.</a:t>
             </a:r>
           </a:p>
           <a:p>
@@ -823,7 +823,7 @@
           <a:lstStyle/>
           <a:p>
             <a:r>
-              <a:t>METODOLOGIA – RIGOR (6:15–8:00). Aqui você mostra método, não código.</a:t>
+              <a:t>METODOLOGIA – RIGOR (6:00–7:45). Aqui você mostra método, não código.</a:t>
             </a:r>
           </a:p>
           <a:p>
@@ -928,7 +928,7 @@
           <a:lstStyle/>
           <a:p>
             <a:r>
-              <a:t>RESULTADOS – PARTE 1 (8:00–10:30). Mostre entrega, não esforço.</a:t>
+              <a:t>RESULTADOS – PARTE 1 (7:45–10:05). Mostre entrega, não esforço.</a:t>
             </a:r>
           </a:p>
           <a:p>
@@ -1043,7 +1043,7 @@
           <a:lstStyle/>
           <a:p>
             <a:r>
-              <a:t>RESULTADOS – PARTE 2 (10:30–12:00).</a:t>
+              <a:t>RESULTADOS – PARTE 2 (10:05–12:00).</a:t>
             </a:r>
           </a:p>
           <a:p/>

</xml_diff>